<commit_message>
Remove the debrief page
Deleted debrief.html and every reference to it. The class-facing flow is
now four steps ending at the exercise; the round ends at its own
scoreboard, and the two-slide framework deck closes the session.

- Dropped the debrief nav step, the landing "Debrief" link, and the
  scoreboard "Debrief" link (HTML + sim.js + copy).
- The framework content the page used to carry now lives in the deck
  (forces + blocker→move) and in the facilitator guide (the pilot trap,
  the three "why agentic" lines, and the discussion prompts are now the
  facilitator's to deliver at the close).
- Folded the shared .debrief CSS into .doc and repointed test.html; no
  .debrief left in the codebase.
- Updated README and BUILD_SPEC (§4.6 marked removed).

Co-Authored-By: Claude Opus 4.8 <noreply@anthropic.com>
</commit_message>
<xml_diff>
--- a/framework-deck.pptx
+++ b/framework-deck.pptx
@@ -5,10 +5,10 @@
     <p:sldMasterId id="2147483648" r:id="rId1"/>
   </p:sldMasterIdLst>
   <p:sldIdLst>
-    <p:sldId id="256" r:id="rId7"/>
-    <p:sldId id="257" r:id="rId8"/>
+    <p:sldId id="256" r:id="rId2"/>
+    <p:sldId id="257" r:id="rId3"/>
   </p:sldIdLst>
-  <p:sldSz cx="12192000" cy="6858000" type="screen4x3"/>
+  <p:sldSz cx="12192000" cy="6858000"/>
   <p:notesSz cx="6858000" cy="9144000"/>
   <p:defaultTextStyle>
     <a:defPPr>
@@ -105,6 +105,22 @@
       </a:defRPr>
     </a:lvl9pPr>
   </p:defaultTextStyle>
+  <p:extLst>
+    <p:ext uri="{EFAFB233-063F-42B5-8137-9DF3F51BA10A}">
+      <p15:sldGuideLst xmlns:p15="http://schemas.microsoft.com/office/powerpoint/2012/main">
+        <p15:guide id="1" orient="horz" pos="2160">
+          <p15:clr>
+            <a:srgbClr val="A4A3A4"/>
+          </p15:clr>
+        </p15:guide>
+        <p15:guide id="2" pos="2880">
+          <p15:clr>
+            <a:srgbClr val="A4A3A4"/>
+          </p15:clr>
+        </p15:guide>
+      </p15:sldGuideLst>
+    </p:ext>
+  </p:extLst>
 </p:presentation>
 </file>
 
@@ -146,10 +162,9 @@
           <a:lstStyle/>
           <a:p>
             <a:r>
-              <a:rPr lang="en-US" smtClean="0"/>
+              <a:rPr lang="en-US"/>
               <a:t>Click to edit Master title style</a:t>
             </a:r>
-            <a:endParaRPr lang="en-US"/>
           </a:p>
         </p:txBody>
       </p:sp>
@@ -265,10 +280,9 @@
           </a:lstStyle>
           <a:p>
             <a:r>
-              <a:rPr lang="en-US" smtClean="0"/>
+              <a:rPr lang="en-US"/>
               <a:t>Click to edit Master subtitle style</a:t>
             </a:r>
-            <a:endParaRPr lang="en-US"/>
           </a:p>
         </p:txBody>
       </p:sp>
@@ -289,7 +303,7 @@
           <a:p>
             <a:fld id="{5BCAD085-E8A6-8845-BD4E-CB4CCA059FC4}" type="datetimeFigureOut">
               <a:rPr lang="en-US" smtClean="0"/>
-              <a:t>1/27/13</a:t>
+              <a:t>9/10/26</a:t>
             </a:fld>
             <a:endParaRPr lang="en-US"/>
           </a:p>
@@ -383,10 +397,9 @@
           <a:lstStyle/>
           <a:p>
             <a:r>
-              <a:rPr lang="en-US" smtClean="0"/>
+              <a:rPr lang="en-US"/>
               <a:t>Click to edit Master title style</a:t>
             </a:r>
-            <a:endParaRPr lang="en-US"/>
           </a:p>
         </p:txBody>
       </p:sp>
@@ -407,38 +420,37 @@
           <a:p>
             <a:pPr lvl="0"/>
             <a:r>
-              <a:rPr lang="en-US" smtClean="0"/>
+              <a:rPr lang="en-US"/>
               <a:t>Click to edit Master text styles</a:t>
             </a:r>
           </a:p>
           <a:p>
             <a:pPr lvl="1"/>
             <a:r>
-              <a:rPr lang="en-US" smtClean="0"/>
+              <a:rPr lang="en-US"/>
               <a:t>Second level</a:t>
             </a:r>
           </a:p>
           <a:p>
             <a:pPr lvl="2"/>
             <a:r>
-              <a:rPr lang="en-US" smtClean="0"/>
+              <a:rPr lang="en-US"/>
               <a:t>Third level</a:t>
             </a:r>
           </a:p>
           <a:p>
             <a:pPr lvl="3"/>
             <a:r>
-              <a:rPr lang="en-US" smtClean="0"/>
+              <a:rPr lang="en-US"/>
               <a:t>Fourth level</a:t>
             </a:r>
           </a:p>
           <a:p>
             <a:pPr lvl="4"/>
             <a:r>
-              <a:rPr lang="en-US" smtClean="0"/>
+              <a:rPr lang="en-US"/>
               <a:t>Fifth level</a:t>
             </a:r>
-            <a:endParaRPr lang="en-US"/>
           </a:p>
         </p:txBody>
       </p:sp>
@@ -459,7 +471,7 @@
           <a:p>
             <a:fld id="{5BCAD085-E8A6-8845-BD4E-CB4CCA059FC4}" type="datetimeFigureOut">
               <a:rPr lang="en-US" smtClean="0"/>
-              <a:t>1/27/13</a:t>
+              <a:t>9/10/26</a:t>
             </a:fld>
             <a:endParaRPr lang="en-US"/>
           </a:p>
@@ -558,10 +570,9 @@
           <a:lstStyle/>
           <a:p>
             <a:r>
-              <a:rPr lang="en-US" smtClean="0"/>
+              <a:rPr lang="en-US"/>
               <a:t>Click to edit Master title style</a:t>
             </a:r>
-            <a:endParaRPr lang="en-US"/>
           </a:p>
         </p:txBody>
       </p:sp>
@@ -587,38 +598,37 @@
           <a:p>
             <a:pPr lvl="0"/>
             <a:r>
-              <a:rPr lang="en-US" smtClean="0"/>
+              <a:rPr lang="en-US"/>
               <a:t>Click to edit Master text styles</a:t>
             </a:r>
           </a:p>
           <a:p>
             <a:pPr lvl="1"/>
             <a:r>
-              <a:rPr lang="en-US" smtClean="0"/>
+              <a:rPr lang="en-US"/>
               <a:t>Second level</a:t>
             </a:r>
           </a:p>
           <a:p>
             <a:pPr lvl="2"/>
             <a:r>
-              <a:rPr lang="en-US" smtClean="0"/>
+              <a:rPr lang="en-US"/>
               <a:t>Third level</a:t>
             </a:r>
           </a:p>
           <a:p>
             <a:pPr lvl="3"/>
             <a:r>
-              <a:rPr lang="en-US" smtClean="0"/>
+              <a:rPr lang="en-US"/>
               <a:t>Fourth level</a:t>
             </a:r>
           </a:p>
           <a:p>
             <a:pPr lvl="4"/>
             <a:r>
-              <a:rPr lang="en-US" smtClean="0"/>
+              <a:rPr lang="en-US"/>
               <a:t>Fifth level</a:t>
             </a:r>
-            <a:endParaRPr lang="en-US"/>
           </a:p>
         </p:txBody>
       </p:sp>
@@ -639,7 +649,7 @@
           <a:p>
             <a:fld id="{5BCAD085-E8A6-8845-BD4E-CB4CCA059FC4}" type="datetimeFigureOut">
               <a:rPr lang="en-US" smtClean="0"/>
-              <a:t>1/27/13</a:t>
+              <a:t>9/10/26</a:t>
             </a:fld>
             <a:endParaRPr lang="en-US"/>
           </a:p>
@@ -733,10 +743,9 @@
           <a:lstStyle/>
           <a:p>
             <a:r>
-              <a:rPr lang="en-US" smtClean="0"/>
+              <a:rPr lang="en-US"/>
               <a:t>Click to edit Master title style</a:t>
             </a:r>
-            <a:endParaRPr lang="en-US"/>
           </a:p>
         </p:txBody>
       </p:sp>
@@ -757,38 +766,37 @@
           <a:p>
             <a:pPr lvl="0"/>
             <a:r>
-              <a:rPr lang="en-US" smtClean="0"/>
+              <a:rPr lang="en-US"/>
               <a:t>Click to edit Master text styles</a:t>
             </a:r>
           </a:p>
           <a:p>
             <a:pPr lvl="1"/>
             <a:r>
-              <a:rPr lang="en-US" smtClean="0"/>
+              <a:rPr lang="en-US"/>
               <a:t>Second level</a:t>
             </a:r>
           </a:p>
           <a:p>
             <a:pPr lvl="2"/>
             <a:r>
-              <a:rPr lang="en-US" smtClean="0"/>
+              <a:rPr lang="en-US"/>
               <a:t>Third level</a:t>
             </a:r>
           </a:p>
           <a:p>
             <a:pPr lvl="3"/>
             <a:r>
-              <a:rPr lang="en-US" smtClean="0"/>
+              <a:rPr lang="en-US"/>
               <a:t>Fourth level</a:t>
             </a:r>
           </a:p>
           <a:p>
             <a:pPr lvl="4"/>
             <a:r>
-              <a:rPr lang="en-US" smtClean="0"/>
+              <a:rPr lang="en-US"/>
               <a:t>Fifth level</a:t>
             </a:r>
-            <a:endParaRPr lang="en-US"/>
           </a:p>
         </p:txBody>
       </p:sp>
@@ -809,7 +817,7 @@
           <a:p>
             <a:fld id="{5BCAD085-E8A6-8845-BD4E-CB4CCA059FC4}" type="datetimeFigureOut">
               <a:rPr lang="en-US" smtClean="0"/>
-              <a:t>1/27/13</a:t>
+              <a:t>9/10/26</a:t>
             </a:fld>
             <a:endParaRPr lang="en-US"/>
           </a:p>
@@ -912,10 +920,9 @@
           </a:lstStyle>
           <a:p>
             <a:r>
-              <a:rPr lang="en-US" smtClean="0"/>
+              <a:rPr lang="en-US"/>
               <a:t>Click to edit Master title style</a:t>
             </a:r>
-            <a:endParaRPr lang="en-US"/>
           </a:p>
         </p:txBody>
       </p:sp>
@@ -1032,7 +1039,7 @@
           <a:p>
             <a:pPr lvl="0"/>
             <a:r>
-              <a:rPr lang="en-US" smtClean="0"/>
+              <a:rPr lang="en-US"/>
               <a:t>Click to edit Master text styles</a:t>
             </a:r>
           </a:p>
@@ -1055,7 +1062,7 @@
           <a:p>
             <a:fld id="{5BCAD085-E8A6-8845-BD4E-CB4CCA059FC4}" type="datetimeFigureOut">
               <a:rPr lang="en-US" smtClean="0"/>
-              <a:t>1/27/13</a:t>
+              <a:t>9/10/26</a:t>
             </a:fld>
             <a:endParaRPr lang="en-US"/>
           </a:p>
@@ -1149,10 +1156,9 @@
           <a:lstStyle/>
           <a:p>
             <a:r>
-              <a:rPr lang="en-US" smtClean="0"/>
+              <a:rPr lang="en-US"/>
               <a:t>Click to edit Master title style</a:t>
             </a:r>
-            <a:endParaRPr lang="en-US"/>
           </a:p>
         </p:txBody>
       </p:sp>
@@ -1206,38 +1212,37 @@
           <a:p>
             <a:pPr lvl="0"/>
             <a:r>
-              <a:rPr lang="en-US" smtClean="0"/>
+              <a:rPr lang="en-US"/>
               <a:t>Click to edit Master text styles</a:t>
             </a:r>
           </a:p>
           <a:p>
             <a:pPr lvl="1"/>
             <a:r>
-              <a:rPr lang="en-US" smtClean="0"/>
+              <a:rPr lang="en-US"/>
               <a:t>Second level</a:t>
             </a:r>
           </a:p>
           <a:p>
             <a:pPr lvl="2"/>
             <a:r>
-              <a:rPr lang="en-US" smtClean="0"/>
+              <a:rPr lang="en-US"/>
               <a:t>Third level</a:t>
             </a:r>
           </a:p>
           <a:p>
             <a:pPr lvl="3"/>
             <a:r>
-              <a:rPr lang="en-US" smtClean="0"/>
+              <a:rPr lang="en-US"/>
               <a:t>Fourth level</a:t>
             </a:r>
           </a:p>
           <a:p>
             <a:pPr lvl="4"/>
             <a:r>
-              <a:rPr lang="en-US" smtClean="0"/>
+              <a:rPr lang="en-US"/>
               <a:t>Fifth level</a:t>
             </a:r>
-            <a:endParaRPr lang="en-US"/>
           </a:p>
         </p:txBody>
       </p:sp>
@@ -1291,38 +1296,37 @@
           <a:p>
             <a:pPr lvl="0"/>
             <a:r>
-              <a:rPr lang="en-US" smtClean="0"/>
+              <a:rPr lang="en-US"/>
               <a:t>Click to edit Master text styles</a:t>
             </a:r>
           </a:p>
           <a:p>
             <a:pPr lvl="1"/>
             <a:r>
-              <a:rPr lang="en-US" smtClean="0"/>
+              <a:rPr lang="en-US"/>
               <a:t>Second level</a:t>
             </a:r>
           </a:p>
           <a:p>
             <a:pPr lvl="2"/>
             <a:r>
-              <a:rPr lang="en-US" smtClean="0"/>
+              <a:rPr lang="en-US"/>
               <a:t>Third level</a:t>
             </a:r>
           </a:p>
           <a:p>
             <a:pPr lvl="3"/>
             <a:r>
-              <a:rPr lang="en-US" smtClean="0"/>
+              <a:rPr lang="en-US"/>
               <a:t>Fourth level</a:t>
             </a:r>
           </a:p>
           <a:p>
             <a:pPr lvl="4"/>
             <a:r>
-              <a:rPr lang="en-US" smtClean="0"/>
+              <a:rPr lang="en-US"/>
               <a:t>Fifth level</a:t>
             </a:r>
-            <a:endParaRPr lang="en-US"/>
           </a:p>
         </p:txBody>
       </p:sp>
@@ -1343,7 +1347,7 @@
           <a:p>
             <a:fld id="{5BCAD085-E8A6-8845-BD4E-CB4CCA059FC4}" type="datetimeFigureOut">
               <a:rPr lang="en-US" smtClean="0"/>
-              <a:t>1/27/13</a:t>
+              <a:t>9/10/26</a:t>
             </a:fld>
             <a:endParaRPr lang="en-US"/>
           </a:p>
@@ -1441,10 +1445,9 @@
           </a:lstStyle>
           <a:p>
             <a:r>
-              <a:rPr lang="en-US" smtClean="0"/>
+              <a:rPr lang="en-US"/>
               <a:t>Click to edit Master title style</a:t>
             </a:r>
-            <a:endParaRPr lang="en-US"/>
           </a:p>
         </p:txBody>
       </p:sp>
@@ -1507,7 +1510,7 @@
           <a:p>
             <a:pPr lvl="0"/>
             <a:r>
-              <a:rPr lang="en-US" smtClean="0"/>
+              <a:rPr lang="en-US"/>
               <a:t>Click to edit Master text styles</a:t>
             </a:r>
           </a:p>
@@ -1563,38 +1566,37 @@
           <a:p>
             <a:pPr lvl="0"/>
             <a:r>
-              <a:rPr lang="en-US" smtClean="0"/>
+              <a:rPr lang="en-US"/>
               <a:t>Click to edit Master text styles</a:t>
             </a:r>
           </a:p>
           <a:p>
             <a:pPr lvl="1"/>
             <a:r>
-              <a:rPr lang="en-US" smtClean="0"/>
+              <a:rPr lang="en-US"/>
               <a:t>Second level</a:t>
             </a:r>
           </a:p>
           <a:p>
             <a:pPr lvl="2"/>
             <a:r>
-              <a:rPr lang="en-US" smtClean="0"/>
+              <a:rPr lang="en-US"/>
               <a:t>Third level</a:t>
             </a:r>
           </a:p>
           <a:p>
             <a:pPr lvl="3"/>
             <a:r>
-              <a:rPr lang="en-US" smtClean="0"/>
+              <a:rPr lang="en-US"/>
               <a:t>Fourth level</a:t>
             </a:r>
           </a:p>
           <a:p>
             <a:pPr lvl="4"/>
             <a:r>
-              <a:rPr lang="en-US" smtClean="0"/>
+              <a:rPr lang="en-US"/>
               <a:t>Fifth level</a:t>
             </a:r>
-            <a:endParaRPr lang="en-US"/>
           </a:p>
         </p:txBody>
       </p:sp>
@@ -1657,7 +1659,7 @@
           <a:p>
             <a:pPr lvl="0"/>
             <a:r>
-              <a:rPr lang="en-US" smtClean="0"/>
+              <a:rPr lang="en-US"/>
               <a:t>Click to edit Master text styles</a:t>
             </a:r>
           </a:p>
@@ -1713,38 +1715,37 @@
           <a:p>
             <a:pPr lvl="0"/>
             <a:r>
-              <a:rPr lang="en-US" smtClean="0"/>
+              <a:rPr lang="en-US"/>
               <a:t>Click to edit Master text styles</a:t>
             </a:r>
           </a:p>
           <a:p>
             <a:pPr lvl="1"/>
             <a:r>
-              <a:rPr lang="en-US" smtClean="0"/>
+              <a:rPr lang="en-US"/>
               <a:t>Second level</a:t>
             </a:r>
           </a:p>
           <a:p>
             <a:pPr lvl="2"/>
             <a:r>
-              <a:rPr lang="en-US" smtClean="0"/>
+              <a:rPr lang="en-US"/>
               <a:t>Third level</a:t>
             </a:r>
           </a:p>
           <a:p>
             <a:pPr lvl="3"/>
             <a:r>
-              <a:rPr lang="en-US" smtClean="0"/>
+              <a:rPr lang="en-US"/>
               <a:t>Fourth level</a:t>
             </a:r>
           </a:p>
           <a:p>
             <a:pPr lvl="4"/>
             <a:r>
-              <a:rPr lang="en-US" smtClean="0"/>
+              <a:rPr lang="en-US"/>
               <a:t>Fifth level</a:t>
             </a:r>
-            <a:endParaRPr lang="en-US"/>
           </a:p>
         </p:txBody>
       </p:sp>
@@ -1765,7 +1766,7 @@
           <a:p>
             <a:fld id="{5BCAD085-E8A6-8845-BD4E-CB4CCA059FC4}" type="datetimeFigureOut">
               <a:rPr lang="en-US" smtClean="0"/>
-              <a:t>1/27/13</a:t>
+              <a:t>9/10/26</a:t>
             </a:fld>
             <a:endParaRPr lang="en-US"/>
           </a:p>
@@ -1859,10 +1860,9 @@
           <a:lstStyle/>
           <a:p>
             <a:r>
-              <a:rPr lang="en-US" smtClean="0"/>
+              <a:rPr lang="en-US"/>
               <a:t>Click to edit Master title style</a:t>
             </a:r>
-            <a:endParaRPr lang="en-US"/>
           </a:p>
         </p:txBody>
       </p:sp>
@@ -1883,7 +1883,7 @@
           <a:p>
             <a:fld id="{5BCAD085-E8A6-8845-BD4E-CB4CCA059FC4}" type="datetimeFigureOut">
               <a:rPr lang="en-US" smtClean="0"/>
-              <a:t>1/27/13</a:t>
+              <a:t>9/10/26</a:t>
             </a:fld>
             <a:endParaRPr lang="en-US"/>
           </a:p>
@@ -1978,7 +1978,7 @@
           <a:p>
             <a:fld id="{5BCAD085-E8A6-8845-BD4E-CB4CCA059FC4}" type="datetimeFigureOut">
               <a:rPr lang="en-US" smtClean="0"/>
-              <a:t>1/27/13</a:t>
+              <a:t>9/10/26</a:t>
             </a:fld>
             <a:endParaRPr lang="en-US"/>
           </a:p>
@@ -2081,10 +2081,9 @@
           </a:lstStyle>
           <a:p>
             <a:r>
-              <a:rPr lang="en-US" smtClean="0"/>
+              <a:rPr lang="en-US"/>
               <a:t>Click to edit Master title style</a:t>
             </a:r>
-            <a:endParaRPr lang="en-US"/>
           </a:p>
         </p:txBody>
       </p:sp>
@@ -2138,38 +2137,37 @@
           <a:p>
             <a:pPr lvl="0"/>
             <a:r>
-              <a:rPr lang="en-US" smtClean="0"/>
+              <a:rPr lang="en-US"/>
               <a:t>Click to edit Master text styles</a:t>
             </a:r>
           </a:p>
           <a:p>
             <a:pPr lvl="1"/>
             <a:r>
-              <a:rPr lang="en-US" smtClean="0"/>
+              <a:rPr lang="en-US"/>
               <a:t>Second level</a:t>
             </a:r>
           </a:p>
           <a:p>
             <a:pPr lvl="2"/>
             <a:r>
-              <a:rPr lang="en-US" smtClean="0"/>
+              <a:rPr lang="en-US"/>
               <a:t>Third level</a:t>
             </a:r>
           </a:p>
           <a:p>
             <a:pPr lvl="3"/>
             <a:r>
-              <a:rPr lang="en-US" smtClean="0"/>
+              <a:rPr lang="en-US"/>
               <a:t>Fourth level</a:t>
             </a:r>
           </a:p>
           <a:p>
             <a:pPr lvl="4"/>
             <a:r>
-              <a:rPr lang="en-US" smtClean="0"/>
+              <a:rPr lang="en-US"/>
               <a:t>Fifth level</a:t>
             </a:r>
-            <a:endParaRPr lang="en-US"/>
           </a:p>
         </p:txBody>
       </p:sp>
@@ -2232,7 +2230,7 @@
           <a:p>
             <a:pPr lvl="0"/>
             <a:r>
-              <a:rPr lang="en-US" smtClean="0"/>
+              <a:rPr lang="en-US"/>
               <a:t>Click to edit Master text styles</a:t>
             </a:r>
           </a:p>
@@ -2255,7 +2253,7 @@
           <a:p>
             <a:fld id="{5BCAD085-E8A6-8845-BD4E-CB4CCA059FC4}" type="datetimeFigureOut">
               <a:rPr lang="en-US" smtClean="0"/>
-              <a:t>1/27/13</a:t>
+              <a:t>9/10/26</a:t>
             </a:fld>
             <a:endParaRPr lang="en-US"/>
           </a:p>
@@ -2358,10 +2356,9 @@
           </a:lstStyle>
           <a:p>
             <a:r>
-              <a:rPr lang="en-US" smtClean="0"/>
+              <a:rPr lang="en-US"/>
               <a:t>Click to edit Master title style</a:t>
             </a:r>
-            <a:endParaRPr lang="en-US"/>
           </a:p>
         </p:txBody>
       </p:sp>
@@ -2485,7 +2482,7 @@
           <a:p>
             <a:pPr lvl="0"/>
             <a:r>
-              <a:rPr lang="en-US" smtClean="0"/>
+              <a:rPr lang="en-US"/>
               <a:t>Click to edit Master text styles</a:t>
             </a:r>
           </a:p>
@@ -2508,7 +2505,7 @@
           <a:p>
             <a:fld id="{5BCAD085-E8A6-8845-BD4E-CB4CCA059FC4}" type="datetimeFigureOut">
               <a:rPr lang="en-US" smtClean="0"/>
-              <a:t>1/27/13</a:t>
+              <a:t>9/10/26</a:t>
             </a:fld>
             <a:endParaRPr lang="en-US"/>
           </a:p>
@@ -2617,10 +2614,9 @@
           <a:lstStyle/>
           <a:p>
             <a:r>
-              <a:rPr lang="en-US" smtClean="0"/>
+              <a:rPr lang="en-US"/>
               <a:t>Click to edit Master title style</a:t>
             </a:r>
-            <a:endParaRPr lang="en-US"/>
           </a:p>
         </p:txBody>
       </p:sp>
@@ -2651,38 +2647,37 @@
           <a:p>
             <a:pPr lvl="0"/>
             <a:r>
-              <a:rPr lang="en-US" smtClean="0"/>
+              <a:rPr lang="en-US"/>
               <a:t>Click to edit Master text styles</a:t>
             </a:r>
           </a:p>
           <a:p>
             <a:pPr lvl="1"/>
             <a:r>
-              <a:rPr lang="en-US" smtClean="0"/>
+              <a:rPr lang="en-US"/>
               <a:t>Second level</a:t>
             </a:r>
           </a:p>
           <a:p>
             <a:pPr lvl="2"/>
             <a:r>
-              <a:rPr lang="en-US" smtClean="0"/>
+              <a:rPr lang="en-US"/>
               <a:t>Third level</a:t>
             </a:r>
           </a:p>
           <a:p>
             <a:pPr lvl="3"/>
             <a:r>
-              <a:rPr lang="en-US" smtClean="0"/>
+              <a:rPr lang="en-US"/>
               <a:t>Fourth level</a:t>
             </a:r>
           </a:p>
           <a:p>
             <a:pPr lvl="4"/>
             <a:r>
-              <a:rPr lang="en-US" smtClean="0"/>
+              <a:rPr lang="en-US"/>
               <a:t>Fifth level</a:t>
             </a:r>
-            <a:endParaRPr lang="en-US"/>
           </a:p>
         </p:txBody>
       </p:sp>
@@ -2721,7 +2716,7 @@
           <a:p>
             <a:fld id="{5BCAD085-E8A6-8845-BD4E-CB4CCA059FC4}" type="datetimeFigureOut">
               <a:rPr lang="en-US" smtClean="0"/>
-              <a:t>1/27/13</a:t>
+              <a:t>9/10/26</a:t>
             </a:fld>
             <a:endParaRPr lang="en-US"/>
           </a:p>
@@ -3080,7 +3075,7 @@
 </file>
 
 <file path=ppt/slides/slide1.xml><?xml version="1.0" encoding="utf-8"?>
-<p:sld xmlns:a="http://schemas.openxmlformats.org/drawingml/2006/main" xmlns:p="http://schemas.openxmlformats.org/presentationml/2006/main" xmlns:r="http://schemas.openxmlformats.org/officeDocument/2006/relationships">
+<p:sld xmlns:a="http://schemas.openxmlformats.org/drawingml/2006/main" xmlns:r="http://schemas.openxmlformats.org/officeDocument/2006/relationships" xmlns:p="http://schemas.openxmlformats.org/presentationml/2006/main">
   <p:cSld>
     <p:spTree>
       <p:nvGrpSpPr>
@@ -3088,7 +3083,14 @@
         <p:cNvGrpSpPr/>
         <p:nvPr/>
       </p:nvGrpSpPr>
-      <p:grpSpPr/>
+      <p:grpSpPr>
+        <a:xfrm>
+          <a:off x="0" y="0"/>
+          <a:ext cx="0" cy="0"/>
+          <a:chOff x="0" y="0"/>
+          <a:chExt cx="0" cy="0"/>
+        </a:xfrm>
+      </p:grpSpPr>
       <p:sp>
         <p:nvSpPr>
           <p:cNvPr id="2" name="Rectangle 1"/>
@@ -3130,19 +3132,20 @@
           <a:lstStyle/>
           <a:p>
             <a:pPr algn="ctr"/>
-          </a:p>
-        </p:txBody>
-      </p:sp>
-      <p:sp>
-        <p:nvSpPr>
-          <p:cNvPr id="3" name="TextBox 2"/>
+            <a:endParaRPr/>
+          </a:p>
+        </p:txBody>
+      </p:sp>
+      <p:sp>
+        <p:nvSpPr>
+          <p:cNvPr id="4" name="TextBox 3"/>
           <p:cNvSpPr txBox="1"/>
           <p:nvPr/>
         </p:nvSpPr>
         <p:spPr>
           <a:xfrm>
-            <a:off x="610000" y="430000"/>
-            <a:ext cx="10972000" cy="300000"/>
+            <a:off x="610000" y="720000"/>
+            <a:ext cx="10972000" cy="1141659"/>
           </a:xfrm>
           <a:prstGeom prst="rect">
             <a:avLst/>
@@ -3150,52 +3153,7 @@
           <a:noFill/>
         </p:spPr>
         <p:txBody>
-          <a:bodyPr wrap="square" lIns="0" rIns="0" tIns="0" bIns="0">
-            <a:spAutoFit/>
-          </a:bodyPr>
-          <a:lstStyle/>
-          <a:p>
-            <a:pPr algn="l">
-              <a:lnSpc>
-                <a:spcPct val="105000"/>
-              </a:lnSpc>
-              <a:spcBef>
-                <a:spcPts val="0"/>
-              </a:spcBef>
-              <a:spcAft>
-                <a:spcPts val="0"/>
-              </a:spcAft>
-            </a:pPr>
-            <a:r>
-              <a:rPr sz="1250" b="1" i="0">
-                <a:solidFill>
-                  <a:srgbClr val="6E7C94"/>
-                </a:solidFill>
-                <a:latin typeface="Calibri"/>
-              </a:rPr>
-              <a:t>T H E   F R A M E W O R K</a:t>
-            </a:r>
-          </a:p>
-        </p:txBody>
-      </p:sp>
-      <p:sp>
-        <p:nvSpPr>
-          <p:cNvPr id="4" name="TextBox 3"/>
-          <p:cNvSpPr txBox="1"/>
-          <p:nvPr/>
-        </p:nvSpPr>
-        <p:spPr>
-          <a:xfrm>
-            <a:off x="610000" y="720000"/>
-            <a:ext cx="10972000" cy="980000"/>
-          </a:xfrm>
-          <a:prstGeom prst="rect">
-            <a:avLst/>
-          </a:prstGeom>
-          <a:noFill/>
-        </p:spPr>
-        <p:txBody>
-          <a:bodyPr wrap="square" lIns="0" rIns="0" tIns="0" bIns="0">
+          <a:bodyPr wrap="square" lIns="0" tIns="0" rIns="0" bIns="0">
             <a:spAutoFit/>
           </a:bodyPr>
           <a:lstStyle/>
@@ -3212,68 +3170,20 @@
               </a:spcAft>
             </a:pPr>
             <a:r>
-              <a:rPr sz="3700" b="0" i="0">
+              <a:rPr lang="en-US" sz="3700" b="0" i="0" dirty="0">
                 <a:solidFill>
                   <a:srgbClr val="FFFFFF"/>
                 </a:solidFill>
                 <a:latin typeface="Calibri Light"/>
               </a:rPr>
-              <a:t>The case for collaborating is never the problem.</a:t>
-            </a:r>
-          </a:p>
-        </p:txBody>
-      </p:sp>
-      <p:sp>
-        <p:nvSpPr>
-          <p:cNvPr id="5" name="TextBox 4"/>
-          <p:cNvSpPr txBox="1"/>
-          <p:nvPr/>
-        </p:nvSpPr>
-        <p:spPr>
-          <a:xfrm>
-            <a:off x="610000" y="1620000"/>
-            <a:ext cx="10972000" cy="560000"/>
-          </a:xfrm>
-          <a:prstGeom prst="rect">
-            <a:avLst/>
-          </a:prstGeom>
-          <a:noFill/>
-        </p:spPr>
-        <p:txBody>
-          <a:bodyPr wrap="square" lIns="0" rIns="0" tIns="0" bIns="0">
-            <a:spAutoFit/>
-          </a:bodyPr>
-          <a:lstStyle/>
-          <a:p>
-            <a:pPr algn="l">
-              <a:lnSpc>
-                <a:spcPct val="112000"/>
-              </a:lnSpc>
-              <a:spcBef>
-                <a:spcPts val="0"/>
-              </a:spcBef>
-              <a:spcAft>
-                <a:spcPts val="0"/>
-              </a:spcAft>
-            </a:pPr>
-            <a:r>
-              <a:rPr sz="1700" b="0" i="0">
-                <a:solidFill>
-                  <a:srgbClr val="9AA7BD"/>
-                </a:solidFill>
-                <a:latin typeface="Calibri"/>
-              </a:rPr>
-              <a:t>Every division agrees the shared asset should exist. What stops each one is specific, legitimate, and rarely about the money — </a:t>
-            </a:r>
-            <a:r>
-              <a:rPr sz="1700" b="1" i="0">
-                <a:solidFill>
-                  <a:srgbClr val="FFFFFF"/>
-                </a:solidFill>
-                <a:latin typeface="Calibri"/>
-              </a:rPr>
-              <a:t>so the work is diagnosis, not persuasion.</a:t>
-            </a:r>
+              <a:t>There are opposing and supporting forces for collaboration</a:t>
+            </a:r>
+            <a:endParaRPr sz="3700" b="0" i="0" dirty="0">
+              <a:solidFill>
+                <a:srgbClr val="FFFFFF"/>
+              </a:solidFill>
+              <a:latin typeface="Calibri Light"/>
+            </a:endParaRPr>
           </a:p>
         </p:txBody>
       </p:sp>
@@ -3318,7 +3228,7 @@
           </a:fontRef>
         </p:style>
         <p:txBody>
-          <a:bodyPr rtlCol="0" anchor="t" wrap="square" lIns="300000" rIns="300000" tIns="260000" bIns="200000"/>
+          <a:bodyPr wrap="square" lIns="300000" tIns="260000" rIns="300000" bIns="200000" rtlCol="0" anchor="t"/>
           <a:lstStyle/>
           <a:p>
             <a:pPr algn="l">
@@ -3333,14 +3243,20 @@
               </a:spcAft>
             </a:pPr>
             <a:r>
-              <a:rPr sz="1400" b="1" i="0">
+              <a:rPr lang="en-US" sz="1400" b="1" i="0" dirty="0">
                 <a:solidFill>
                   <a:srgbClr val="3FD9A0"/>
                 </a:solidFill>
                 <a:latin typeface="Calibri"/>
               </a:rPr>
-              <a:t>WHY THEY COME TO THE TABLE</a:t>
-            </a:r>
+              <a:t>Supporting forces for collaboration </a:t>
+            </a:r>
+            <a:endParaRPr sz="1400" b="1" i="0" dirty="0">
+              <a:solidFill>
+                <a:srgbClr val="3FD9A0"/>
+              </a:solidFill>
+              <a:latin typeface="Calibri"/>
+            </a:endParaRPr>
           </a:p>
           <a:p>
             <a:pPr algn="l">
@@ -3355,7 +3271,7 @@
               </a:spcAft>
             </a:pPr>
             <a:r>
-              <a:rPr sz="1250" b="0" i="1">
+              <a:rPr sz="1250" b="0" i="1" dirty="0">
                 <a:solidFill>
                   <a:srgbClr val="6E7C94"/>
                 </a:solidFill>
@@ -3377,23 +3293,47 @@
               </a:spcAft>
             </a:pPr>
             <a:r>
-              <a:rPr sz="1500" b="1" i="0">
+              <a:rPr sz="1500" b="1" i="0" dirty="0">
                 <a:solidFill>
                   <a:srgbClr val="FFFFFF"/>
                 </a:solidFill>
                 <a:latin typeface="Calibri"/>
               </a:rPr>
-              <a:t>Dependency.  </a:t>
-            </a:r>
-            <a:r>
-              <a:rPr sz="1400" b="0" i="0">
-                <a:solidFill>
-                  <a:srgbClr val="9AA7BD"/>
+              <a:t>Dependency</a:t>
+            </a:r>
+            <a:r>
+              <a:rPr lang="en-US" sz="1500" b="1" dirty="0">
+                <a:solidFill>
+                  <a:srgbClr val="FFFFFF"/>
                 </a:solidFill>
                 <a:latin typeface="Calibri"/>
               </a:rPr>
-              <a:t>Your value depends on an asset another division owns. Own that asset yourself, and your upside is their commitment, not your roadmap.</a:t>
-            </a:r>
+              <a:t>: </a:t>
+            </a:r>
+            <a:r>
+              <a:rPr lang="en-US" sz="1400" b="0" i="0" dirty="0">
+                <a:solidFill>
+                  <a:srgbClr val="9AA7BD"/>
+                </a:solidFill>
+                <a:latin typeface="Calibri"/>
+              </a:rPr>
+              <a:t>Value realization d</a:t>
+            </a:r>
+            <a:r>
+              <a:rPr sz="1400" b="0" i="0" dirty="0">
+                <a:solidFill>
+                  <a:srgbClr val="9AA7BD"/>
+                </a:solidFill>
+                <a:latin typeface="Calibri"/>
+              </a:rPr>
+              <a:t>epends on an asset another division owns. </a:t>
+            </a:r>
+            <a:endParaRPr lang="en-US" sz="1400" b="0" i="0" dirty="0">
+              <a:solidFill>
+                <a:srgbClr val="9AA7BD"/>
+              </a:solidFill>
+              <a:latin typeface="Calibri"/>
+            </a:endParaRPr>
           </a:p>
           <a:p>
             <a:pPr algn="l">
@@ -3408,22 +3348,58 @@
               </a:spcAft>
             </a:pPr>
             <a:r>
-              <a:rPr sz="1500" b="1" i="0">
+              <a:rPr sz="1500" b="1" i="0" dirty="0">
                 <a:solidFill>
                   <a:srgbClr val="FFFFFF"/>
                 </a:solidFill>
                 <a:latin typeface="Calibri"/>
               </a:rPr>
-              <a:t>Threshold.  </a:t>
-            </a:r>
-            <a:r>
-              <a:rPr sz="1400" b="0" i="0">
-                <a:solidFill>
-                  <a:srgbClr val="9AA7BD"/>
+              <a:t>Threshold</a:t>
+            </a:r>
+            <a:r>
+              <a:rPr lang="en-US" sz="1500" b="1" i="0" dirty="0">
+                <a:solidFill>
+                  <a:srgbClr val="FFFFFF"/>
                 </a:solidFill>
                 <a:latin typeface="Calibri"/>
               </a:rPr>
-              <a:t>The asset is lumpy. It exists only above a funding line no single owner can justify alone — so it is built jointly or not at all.</a:t>
+              <a:t>:</a:t>
+            </a:r>
+            <a:r>
+              <a:rPr sz="1500" b="1" i="0" dirty="0">
+                <a:solidFill>
+                  <a:srgbClr val="FFFFFF"/>
+                </a:solidFill>
+                <a:latin typeface="Calibri"/>
+              </a:rPr>
+              <a:t>  </a:t>
+            </a:r>
+            <a:r>
+              <a:rPr lang="en-US" sz="1400" b="0" i="0" dirty="0">
+                <a:solidFill>
+                  <a:srgbClr val="9AA7BD"/>
+                </a:solidFill>
+                <a:latin typeface="Calibri"/>
+              </a:rPr>
+              <a:t>Funding AI platforms require a minimum funding and quality threshold that </a:t>
+            </a:r>
+            <a:r>
+              <a:rPr sz="1400" b="0" i="0" dirty="0">
+                <a:solidFill>
+                  <a:srgbClr val="9AA7BD"/>
+                </a:solidFill>
+                <a:latin typeface="Calibri"/>
+              </a:rPr>
+              <a:t>no single owner can </a:t>
+            </a:r>
+            <a:r>
+              <a:rPr lang="en-US" sz="1400" b="0" i="0" dirty="0">
+                <a:solidFill>
+                  <a:srgbClr val="9AA7BD"/>
+                </a:solidFill>
+                <a:latin typeface="Calibri"/>
+              </a:rPr>
+              <a:t>own alone, so it must be built jointly </a:t>
             </a:r>
           </a:p>
           <a:p>
@@ -3439,16 +3415,16 @@
               </a:spcAft>
             </a:pPr>
             <a:r>
-              <a:rPr sz="1500" b="1" i="0">
+              <a:rPr lang="en-US" sz="1500" b="1" i="0" dirty="0">
                 <a:solidFill>
                   <a:srgbClr val="FFFFFF"/>
                 </a:solidFill>
                 <a:latin typeface="Calibri"/>
               </a:rPr>
-              <a:t>Duplication.  </a:t>
-            </a:r>
-            <a:r>
-              <a:rPr sz="1400" b="0" i="0">
+              <a:t>Duplication:  </a:t>
+            </a:r>
+            <a:r>
+              <a:rPr lang="en-US" sz="1400" b="0" i="0" dirty="0">
                 <a:solidFill>
                   <a:srgbClr val="9AA7BD"/>
                 </a:solidFill>
@@ -3500,7 +3476,7 @@
           </a:fontRef>
         </p:style>
         <p:txBody>
-          <a:bodyPr rtlCol="0" anchor="t" wrap="square" lIns="300000" rIns="300000" tIns="260000" bIns="200000"/>
+          <a:bodyPr wrap="square" lIns="300000" tIns="260000" rIns="300000" bIns="200000" rtlCol="0" anchor="t"/>
           <a:lstStyle/>
           <a:p>
             <a:pPr algn="l">
@@ -3515,14 +3491,20 @@
               </a:spcAft>
             </a:pPr>
             <a:r>
-              <a:rPr sz="1400" b="1" i="0">
+              <a:rPr lang="en-US" sz="1400" b="1" i="0" dirty="0">
                 <a:solidFill>
                   <a:srgbClr val="F0685F"/>
                 </a:solidFill>
                 <a:latin typeface="Calibri"/>
               </a:rPr>
-              <a:t>WHY THEY DEFEND THEIR PLAN</a:t>
-            </a:r>
+              <a:t>Opposing forces for collaboration </a:t>
+            </a:r>
+            <a:endParaRPr sz="1400" b="1" i="0" dirty="0">
+              <a:solidFill>
+                <a:srgbClr val="F0685F"/>
+              </a:solidFill>
+              <a:latin typeface="Calibri"/>
+            </a:endParaRPr>
           </a:p>
           <a:p>
             <a:pPr algn="l">
@@ -3537,7 +3519,7 @@
               </a:spcAft>
             </a:pPr>
             <a:r>
-              <a:rPr sz="1250" b="0" i="1">
+              <a:rPr sz="1250" b="0" i="1" dirty="0">
                 <a:solidFill>
                   <a:srgbClr val="6E7C94"/>
                 </a:solidFill>
@@ -3559,23 +3541,47 @@
               </a:spcAft>
             </a:pPr>
             <a:r>
-              <a:rPr sz="1500" b="1" i="0">
+              <a:rPr lang="en-US" sz="1500" b="1" i="0" dirty="0">
                 <a:solidFill>
                   <a:srgbClr val="FFFFFF"/>
                 </a:solidFill>
                 <a:latin typeface="Calibri"/>
               </a:rPr>
-              <a:t>Timing.  </a:t>
-            </a:r>
-            <a:r>
-              <a:rPr sz="1400" b="0" i="0">
-                <a:solidFill>
-                  <a:srgbClr val="9AA7BD"/>
+              <a:t>Absorption:</a:t>
+            </a:r>
+            <a:r>
+              <a:rPr sz="1500" b="1" i="0" dirty="0">
+                <a:solidFill>
+                  <a:srgbClr val="FFFFFF"/>
                 </a:solidFill>
                 <a:latin typeface="Calibri"/>
               </a:rPr>
-              <a:t>Cannot take this much change this fast. A capacity problem, not a size one.</a:t>
-            </a:r>
+              <a:t>  </a:t>
+            </a:r>
+            <a:r>
+              <a:rPr sz="1400" b="0" i="0" dirty="0">
+                <a:solidFill>
+                  <a:srgbClr val="9AA7BD"/>
+                </a:solidFill>
+                <a:latin typeface="Calibri"/>
+              </a:rPr>
+              <a:t>Cannot </a:t>
+            </a:r>
+            <a:r>
+              <a:rPr lang="en-US" sz="1400" b="0" i="0" dirty="0">
+                <a:solidFill>
+                  <a:srgbClr val="9AA7BD"/>
+                </a:solidFill>
+                <a:latin typeface="Calibri"/>
+              </a:rPr>
+              <a:t>absorb high rate of change quickly, this is a timing constraint </a:t>
+            </a:r>
+            <a:endParaRPr sz="1400" b="0" i="0" dirty="0">
+              <a:solidFill>
+                <a:srgbClr val="9AA7BD"/>
+              </a:solidFill>
+              <a:latin typeface="Calibri"/>
+            </a:endParaRPr>
           </a:p>
           <a:p>
             <a:pPr algn="l">
@@ -3590,16 +3596,25 @@
               </a:spcAft>
             </a:pPr>
             <a:r>
-              <a:rPr sz="1500" b="1" i="0">
+              <a:rPr lang="en-US" sz="1500" b="1" i="0" dirty="0">
                 <a:solidFill>
                   <a:srgbClr val="FFFFFF"/>
                 </a:solidFill>
                 <a:latin typeface="Calibri"/>
               </a:rPr>
-              <a:t>Head start.  </a:t>
-            </a:r>
-            <a:r>
-              <a:rPr sz="1400" b="0" i="0">
+              <a:t>Advantage:</a:t>
+            </a:r>
+            <a:r>
+              <a:rPr sz="1500" b="1" i="0" dirty="0">
+                <a:solidFill>
+                  <a:srgbClr val="FFFFFF"/>
+                </a:solidFill>
+                <a:latin typeface="Calibri"/>
+              </a:rPr>
+              <a:t>  </a:t>
+            </a:r>
+            <a:r>
+              <a:rPr sz="1400" b="0" i="0" dirty="0">
                 <a:solidFill>
                   <a:srgbClr val="9AA7BD"/>
                 </a:solidFill>
@@ -3607,6 +3622,44 @@
               </a:rPr>
               <a:t>Already ahead, and unwilling to fund the others catching up.</a:t>
             </a:r>
+            <a:endParaRPr lang="en-US" sz="1400" b="0" i="0" dirty="0">
+              <a:solidFill>
+                <a:srgbClr val="9AA7BD"/>
+              </a:solidFill>
+              <a:latin typeface="Calibri"/>
+            </a:endParaRPr>
+          </a:p>
+          <a:p>
+            <a:pPr>
+              <a:lnSpc>
+                <a:spcPct val="106000"/>
+              </a:lnSpc>
+              <a:spcAft>
+                <a:spcPts val="1000"/>
+              </a:spcAft>
+            </a:pPr>
+            <a:r>
+              <a:rPr lang="en-US" sz="1500" b="1" dirty="0">
+                <a:solidFill>
+                  <a:srgbClr val="FFFFFF"/>
+                </a:solidFill>
+              </a:rPr>
+              <a:t>Assurance:  </a:t>
+            </a:r>
+            <a:r>
+              <a:rPr lang="en-US" sz="1400" dirty="0">
+                <a:solidFill>
+                  <a:srgbClr val="9AA7BD"/>
+                </a:solidFill>
+              </a:rPr>
+              <a:t>Low trust in upside potential and wider organization </a:t>
+            </a:r>
+            <a:endParaRPr sz="1400" b="0" i="0" dirty="0">
+              <a:solidFill>
+                <a:srgbClr val="9AA7BD"/>
+              </a:solidFill>
+              <a:latin typeface="Calibri"/>
+            </a:endParaRPr>
           </a:p>
           <a:p>
             <a:pPr algn="l">
@@ -3621,98 +3674,40 @@
               </a:spcAft>
             </a:pPr>
             <a:r>
-              <a:rPr sz="1500" b="1" i="0">
+              <a:rPr sz="1500" b="1" i="0" dirty="0">
                 <a:solidFill>
                   <a:srgbClr val="FFFFFF"/>
                 </a:solidFill>
                 <a:latin typeface="Calibri"/>
               </a:rPr>
-              <a:t>Standing.  </a:t>
-            </a:r>
-            <a:r>
-              <a:rPr sz="1400" b="0" i="0">
+              <a:t>Standin</a:t>
+            </a:r>
+            <a:r>
+              <a:rPr lang="en-US" sz="1500" b="1" i="0" dirty="0">
+                <a:solidFill>
+                  <a:srgbClr val="FFFFFF"/>
+                </a:solidFill>
+                <a:latin typeface="Calibri"/>
+              </a:rPr>
+              <a:t>g:</a:t>
+            </a:r>
+            <a:r>
+              <a:rPr sz="1500" b="1" i="0" dirty="0">
+                <a:solidFill>
+                  <a:srgbClr val="FFFFFF"/>
+                </a:solidFill>
+                <a:latin typeface="Calibri"/>
+              </a:rPr>
+              <a:t>  </a:t>
+            </a:r>
+            <a:r>
+              <a:rPr sz="1400" b="0" i="0" dirty="0">
                 <a:solidFill>
                   <a:srgbClr val="9AA7BD"/>
                 </a:solidFill>
                 <a:latin typeface="Calibri"/>
               </a:rPr>
               <a:t>Will not dissolve a hard-won lead into a shared, equal asset.</a:t>
-            </a:r>
-          </a:p>
-          <a:p>
-            <a:pPr algn="l">
-              <a:lnSpc>
-                <a:spcPct val="106000"/>
-              </a:lnSpc>
-              <a:spcBef>
-                <a:spcPts val="0"/>
-              </a:spcBef>
-              <a:spcAft>
-                <a:spcPts val="1000"/>
-              </a:spcAft>
-            </a:pPr>
-            <a:r>
-              <a:rPr sz="1500" b="1" i="0">
-                <a:solidFill>
-                  <a:srgbClr val="FFFFFF"/>
-                </a:solidFill>
-                <a:latin typeface="Calibri"/>
-              </a:rPr>
-              <a:t>Trust.  </a:t>
-            </a:r>
-            <a:r>
-              <a:rPr sz="1400" b="0" i="0">
-                <a:solidFill>
-                  <a:srgbClr val="9AA7BD"/>
-                </a:solidFill>
-                <a:latin typeface="Calibri"/>
-              </a:rPr>
-              <a:t>Ate the cost of the last central mandate, and expects to again.</a:t>
-            </a:r>
-          </a:p>
-        </p:txBody>
-      </p:sp>
-      <p:sp>
-        <p:nvSpPr>
-          <p:cNvPr id="8" name="TextBox 7"/>
-          <p:cNvSpPr txBox="1"/>
-          <p:nvPr/>
-        </p:nvSpPr>
-        <p:spPr>
-          <a:xfrm>
-            <a:off x="610000" y="6300000"/>
-            <a:ext cx="10972000" cy="320000"/>
-          </a:xfrm>
-          <a:prstGeom prst="rect">
-            <a:avLst/>
-          </a:prstGeom>
-          <a:noFill/>
-        </p:spPr>
-        <p:txBody>
-          <a:bodyPr wrap="square" lIns="0" rIns="0" tIns="0" bIns="0">
-            <a:spAutoFit/>
-          </a:bodyPr>
-          <a:lstStyle/>
-          <a:p>
-            <a:pPr algn="l">
-              <a:lnSpc>
-                <a:spcPct val="105000"/>
-              </a:lnSpc>
-              <a:spcBef>
-                <a:spcPts val="0"/>
-              </a:spcBef>
-              <a:spcAft>
-                <a:spcPts val="0"/>
-              </a:spcAft>
-            </a:pPr>
-            <a:r>
-              <a:rPr sz="1450" b="1" i="0">
-                <a:solidFill>
-                  <a:srgbClr val="3FD9A0"/>
-                </a:solidFill>
-                <a:latin typeface="Calibri"/>
-              </a:rPr>
-              <a:t>Win the left in principle for free. You only get a number by answering the right.</a:t>
             </a:r>
           </a:p>
         </p:txBody>
@@ -3726,7 +3721,7 @@
 </file>
 
 <file path=ppt/slides/slide2.xml><?xml version="1.0" encoding="utf-8"?>
-<p:sld xmlns:a="http://schemas.openxmlformats.org/drawingml/2006/main" xmlns:p="http://schemas.openxmlformats.org/presentationml/2006/main" xmlns:r="http://schemas.openxmlformats.org/officeDocument/2006/relationships">
+<p:sld xmlns:a="http://schemas.openxmlformats.org/drawingml/2006/main" xmlns:r="http://schemas.openxmlformats.org/officeDocument/2006/relationships" xmlns:p="http://schemas.openxmlformats.org/presentationml/2006/main">
   <p:cSld>
     <p:spTree>
       <p:nvGrpSpPr>
@@ -3734,7 +3729,14 @@
         <p:cNvGrpSpPr/>
         <p:nvPr/>
       </p:nvGrpSpPr>
-      <p:grpSpPr/>
+      <p:grpSpPr>
+        <a:xfrm>
+          <a:off x="0" y="0"/>
+          <a:ext cx="0" cy="0"/>
+          <a:chOff x="0" y="0"/>
+          <a:chExt cx="0" cy="0"/>
+        </a:xfrm>
+      </p:grpSpPr>
       <p:sp>
         <p:nvSpPr>
           <p:cNvPr id="2" name="Rectangle 1"/>
@@ -3776,19 +3778,20 @@
           <a:lstStyle/>
           <a:p>
             <a:pPr algn="ctr"/>
-          </a:p>
-        </p:txBody>
-      </p:sp>
-      <p:sp>
-        <p:nvSpPr>
-          <p:cNvPr id="3" name="TextBox 2"/>
+            <a:endParaRPr/>
+          </a:p>
+        </p:txBody>
+      </p:sp>
+      <p:sp>
+        <p:nvSpPr>
+          <p:cNvPr id="4" name="TextBox 3"/>
           <p:cNvSpPr txBox="1"/>
           <p:nvPr/>
         </p:nvSpPr>
         <p:spPr>
           <a:xfrm>
-            <a:off x="610000" y="430000"/>
-            <a:ext cx="10972000" cy="300000"/>
+            <a:off x="610000" y="720000"/>
+            <a:ext cx="10972000" cy="1049070"/>
           </a:xfrm>
           <a:prstGeom prst="rect">
             <a:avLst/>
@@ -3796,52 +3799,7 @@
           <a:noFill/>
         </p:spPr>
         <p:txBody>
-          <a:bodyPr wrap="square" lIns="0" rIns="0" tIns="0" bIns="0">
-            <a:spAutoFit/>
-          </a:bodyPr>
-          <a:lstStyle/>
-          <a:p>
-            <a:pPr algn="l">
-              <a:lnSpc>
-                <a:spcPct val="105000"/>
-              </a:lnSpc>
-              <a:spcBef>
-                <a:spcPts val="0"/>
-              </a:spcBef>
-              <a:spcAft>
-                <a:spcPts val="0"/>
-              </a:spcAft>
-            </a:pPr>
-            <a:r>
-              <a:rPr sz="1250" b="1" i="0">
-                <a:solidFill>
-                  <a:srgbClr val="6E7C94"/>
-                </a:solidFill>
-                <a:latin typeface="Calibri"/>
-              </a:rPr>
-              <a:t>T H E   F R A M E W O R K ,   A P P L I E D</a:t>
-            </a:r>
-          </a:p>
-        </p:txBody>
-      </p:sp>
-      <p:sp>
-        <p:nvSpPr>
-          <p:cNvPr id="4" name="TextBox 3"/>
-          <p:cNvSpPr txBox="1"/>
-          <p:nvPr/>
-        </p:nvSpPr>
-        <p:spPr>
-          <a:xfrm>
-            <a:off x="610000" y="720000"/>
-            <a:ext cx="10972000" cy="700000"/>
-          </a:xfrm>
-          <a:prstGeom prst="rect">
-            <a:avLst/>
-          </a:prstGeom>
-          <a:noFill/>
-        </p:spPr>
-        <p:txBody>
-          <a:bodyPr wrap="square" lIns="0" rIns="0" tIns="0" bIns="0">
+          <a:bodyPr wrap="square" lIns="0" tIns="0" rIns="0" bIns="0">
             <a:spAutoFit/>
           </a:bodyPr>
           <a:lstStyle/>
@@ -3858,68 +3816,20 @@
               </a:spcAft>
             </a:pPr>
             <a:r>
-              <a:rPr sz="3400" b="0" i="0">
+              <a:rPr lang="en-US" sz="3400" b="0" i="0" dirty="0">
                 <a:solidFill>
                   <a:srgbClr val="FFFFFF"/>
                 </a:solidFill>
                 <a:latin typeface="Calibri Light"/>
               </a:rPr>
-              <a:t>Diagnose the blocker. Deploy the one move that answers it.</a:t>
-            </a:r>
-          </a:p>
-        </p:txBody>
-      </p:sp>
-      <p:sp>
-        <p:nvSpPr>
-          <p:cNvPr id="5" name="TextBox 4"/>
-          <p:cNvSpPr txBox="1"/>
-          <p:nvPr/>
-        </p:nvSpPr>
-        <p:spPr>
-          <a:xfrm>
-            <a:off x="610000" y="1470000"/>
-            <a:ext cx="10972000" cy="560000"/>
-          </a:xfrm>
-          <a:prstGeom prst="rect">
-            <a:avLst/>
-          </a:prstGeom>
-          <a:noFill/>
-        </p:spPr>
-        <p:txBody>
-          <a:bodyPr wrap="square" lIns="0" rIns="0" tIns="0" bIns="0">
-            <a:spAutoFit/>
-          </a:bodyPr>
-          <a:lstStyle/>
-          <a:p>
-            <a:pPr algn="l">
-              <a:lnSpc>
-                <a:spcPct val="112000"/>
-              </a:lnSpc>
-              <a:spcBef>
-                <a:spcPts val="0"/>
-              </a:spcBef>
-              <a:spcAft>
-                <a:spcPts val="0"/>
-              </a:spcAft>
-            </a:pPr>
-            <a:r>
-              <a:rPr sz="1650" b="0" i="0">
-                <a:solidFill>
-                  <a:srgbClr val="9AA7BD"/>
-                </a:solidFill>
-                <a:latin typeface="Calibri"/>
-              </a:rPr>
-              <a:t>Reach for money by default and you overpay for three blockers out of four — and still miss them. </a:t>
-            </a:r>
-            <a:r>
-              <a:rPr sz="1650" b="1" i="0">
-                <a:solidFill>
-                  <a:srgbClr val="FFFFFF"/>
-                </a:solidFill>
-                <a:latin typeface="Calibri"/>
-              </a:rPr>
-              <a:t>Match the move to the block.</a:t>
-            </a:r>
+              <a:t>Each blocker requires a specific enterprise mandate and it’s not all about money  </a:t>
+            </a:r>
+            <a:endParaRPr sz="3400" b="0" i="0" dirty="0">
+              <a:solidFill>
+                <a:srgbClr val="FFFFFF"/>
+              </a:solidFill>
+              <a:latin typeface="Calibri Light"/>
+            </a:endParaRPr>
           </a:p>
         </p:txBody>
       </p:sp>
@@ -3929,7 +3839,13 @@
           <p:cNvGraphicFramePr>
             <a:graphicFrameLocks noGrp="1"/>
           </p:cNvGraphicFramePr>
-          <p:nvPr/>
+          <p:nvPr>
+            <p:extLst>
+              <p:ext uri="{D42A27DB-BD31-4B8C-83A1-F6EECF244321}">
+                <p14:modId xmlns:p14="http://schemas.microsoft.com/office/powerpoint/2010/main" val="310553929"/>
+              </p:ext>
+            </p:extLst>
+          </p:nvPr>
         </p:nvGraphicFramePr>
         <p:xfrm>
           <a:off x="610000" y="2200000"/>
@@ -3942,14 +3858,32 @@
                 <a:tableStyleId>{5C22544A-7EE6-4342-B048-85BDC9FD1C3A}</a:tableStyleId>
               </a:tblPr>
               <a:tblGrid>
-                <a:gridCol w="3560000"/>
-                <a:gridCol w="2320000"/>
-                <a:gridCol w="5092000"/>
+                <a:gridCol w="3560000">
+                  <a:extLst>
+                    <a:ext uri="{9D8B030D-6E8A-4147-A177-3AD203B41FA5}">
+                      <a16:colId xmlns:a16="http://schemas.microsoft.com/office/drawing/2014/main" val="20000"/>
+                    </a:ext>
+                  </a:extLst>
+                </a:gridCol>
+                <a:gridCol w="2320000">
+                  <a:extLst>
+                    <a:ext uri="{9D8B030D-6E8A-4147-A177-3AD203B41FA5}">
+                      <a16:colId xmlns:a16="http://schemas.microsoft.com/office/drawing/2014/main" val="20001"/>
+                    </a:ext>
+                  </a:extLst>
+                </a:gridCol>
+                <a:gridCol w="5092000">
+                  <a:extLst>
+                    <a:ext uri="{9D8B030D-6E8A-4147-A177-3AD203B41FA5}">
+                      <a16:colId xmlns:a16="http://schemas.microsoft.com/office/drawing/2014/main" val="20002"/>
+                    </a:ext>
+                  </a:extLst>
+                </a:gridCol>
               </a:tblGrid>
               <a:tr h="470000">
                 <a:tc>
                   <a:txBody>
-                    <a:bodyPr wrap="square" lIns="150000" rIns="150000" tIns="90000" bIns="90000"/>
+                    <a:bodyPr/>
                     <a:lstStyle/>
                     <a:p>
                       <a:pPr algn="l">
@@ -3964,30 +3898,31 @@
                         </a:spcAft>
                       </a:pPr>
                       <a:r>
-                        <a:rPr sz="1150" b="1" i="0">
+                        <a:rPr lang="en-US" sz="1150" b="1" i="0" dirty="0">
                           <a:solidFill>
                             <a:srgbClr val="6E7C94"/>
                           </a:solidFill>
                           <a:latin typeface="Calibri"/>
                         </a:rPr>
-                        <a:t>THE BLOCKER  —  what you hear</a:t>
+                        <a:t>Internal division dialogue </a:t>
                       </a:r>
+                      <a:endParaRPr sz="1150" b="1" i="0" dirty="0">
+                        <a:solidFill>
+                          <a:srgbClr val="6E7C94"/>
+                        </a:solidFill>
+                        <a:latin typeface="Calibri"/>
+                      </a:endParaRPr>
                     </a:p>
                   </a:txBody>
                   <a:tcPr anchor="ctr">
                     <a:solidFill>
                       <a:srgbClr val="121B2E"/>
                     </a:solidFill>
-                    <a:lnB w="9525" cap="flat">
-                      <a:solidFill>
-                        <a:srgbClr val="27334B"/>
-                      </a:solidFill>
-                    </a:lnB>
                   </a:tcPr>
                 </a:tc>
                 <a:tc>
                   <a:txBody>
-                    <a:bodyPr wrap="square" lIns="150000" rIns="150000" tIns="90000" bIns="90000"/>
+                    <a:bodyPr/>
                     <a:lstStyle/>
                     <a:p>
                       <a:pPr algn="l">
@@ -4002,30 +3937,31 @@
                         </a:spcAft>
                       </a:pPr>
                       <a:r>
-                        <a:rPr sz="1150" b="1" i="0">
+                        <a:rPr lang="en-US" sz="1150" b="1" i="0" dirty="0">
                           <a:solidFill>
                             <a:srgbClr val="6E7C94"/>
                           </a:solidFill>
                           <a:latin typeface="Calibri"/>
                         </a:rPr>
-                        <a:t>WHAT IT REALLY IS</a:t>
+                        <a:t>What it really is </a:t>
                       </a:r>
+                      <a:endParaRPr sz="1150" b="1" i="0" dirty="0">
+                        <a:solidFill>
+                          <a:srgbClr val="6E7C94"/>
+                        </a:solidFill>
+                        <a:latin typeface="Calibri"/>
+                      </a:endParaRPr>
                     </a:p>
                   </a:txBody>
                   <a:tcPr anchor="ctr">
                     <a:solidFill>
                       <a:srgbClr val="121B2E"/>
                     </a:solidFill>
-                    <a:lnB w="9525" cap="flat">
-                      <a:solidFill>
-                        <a:srgbClr val="27334B"/>
-                      </a:solidFill>
-                    </a:lnB>
                   </a:tcPr>
                 </a:tc>
                 <a:tc>
                   <a:txBody>
-                    <a:bodyPr wrap="square" lIns="150000" rIns="150000" tIns="90000" bIns="90000"/>
+                    <a:bodyPr/>
                     <a:lstStyle/>
                     <a:p>
                       <a:pPr algn="l">
@@ -4040,32 +3976,38 @@
                         </a:spcAft>
                       </a:pPr>
                       <a:r>
-                        <a:rPr sz="1150" b="1" i="0">
+                        <a:rPr lang="en-US" sz="1150" b="1" i="0" dirty="0">
                           <a:solidFill>
                             <a:srgbClr val="6E7C94"/>
                           </a:solidFill>
                           <a:latin typeface="Calibri"/>
                         </a:rPr>
-                        <a:t>THE MOVE THAT BUYS THEM IN</a:t>
+                        <a:t>Effective enterprise mandate </a:t>
                       </a:r>
+                      <a:endParaRPr sz="1150" b="1" i="0" dirty="0">
+                        <a:solidFill>
+                          <a:srgbClr val="6E7C94"/>
+                        </a:solidFill>
+                        <a:latin typeface="Calibri"/>
+                      </a:endParaRPr>
                     </a:p>
                   </a:txBody>
                   <a:tcPr anchor="ctr">
                     <a:solidFill>
                       <a:srgbClr val="121B2E"/>
                     </a:solidFill>
-                    <a:lnB w="9525" cap="flat">
-                      <a:solidFill>
-                        <a:srgbClr val="27334B"/>
-                      </a:solidFill>
-                    </a:lnB>
                   </a:tcPr>
                 </a:tc>
+                <a:extLst>
+                  <a:ext uri="{0D108BD9-81ED-4DB2-BD59-A6C34878D82A}">
+                    <a16:rowId xmlns:a16="http://schemas.microsoft.com/office/drawing/2014/main" val="10000"/>
+                  </a:ext>
+                </a:extLst>
               </a:tr>
               <a:tr h="857000">
                 <a:tc>
                   <a:txBody>
-                    <a:bodyPr wrap="square" lIns="150000" rIns="150000" tIns="90000" bIns="90000"/>
+                    <a:bodyPr/>
                     <a:lstStyle/>
                     <a:p>
                       <a:pPr algn="l">
@@ -4080,13 +4022,31 @@
                         </a:spcAft>
                       </a:pPr>
                       <a:r>
-                        <a:rPr sz="1550" b="1" i="0">
+                        <a:rPr sz="1550" b="1" i="0" dirty="0">
                           <a:solidFill>
                             <a:srgbClr val="FFFFFF"/>
                           </a:solidFill>
                           <a:latin typeface="Calibri"/>
                         </a:rPr>
-                        <a:t>"We can’t absorb this now."</a:t>
+                        <a:t>"We </a:t>
+                      </a:r>
+                      <a:r>
+                        <a:rPr lang="en-US" sz="1550" b="1" i="0" dirty="0">
+                          <a:solidFill>
+                            <a:srgbClr val="FFFFFF"/>
+                          </a:solidFill>
+                          <a:latin typeface="Calibri"/>
+                        </a:rPr>
+                        <a:t>can’t deviate from our plan now</a:t>
+                      </a:r>
+                      <a:r>
+                        <a:rPr sz="1550" b="1" i="0" dirty="0">
+                          <a:solidFill>
+                            <a:srgbClr val="FFFFFF"/>
+                          </a:solidFill>
+                          <a:latin typeface="Calibri"/>
+                        </a:rPr>
+                        <a:t>."</a:t>
                       </a:r>
                     </a:p>
                   </a:txBody>
@@ -4094,16 +4054,11 @@
                     <a:solidFill>
                       <a:srgbClr val="1A2337"/>
                     </a:solidFill>
-                    <a:lnB w="9525" cap="flat">
-                      <a:solidFill>
-                        <a:srgbClr val="27334B"/>
-                      </a:solidFill>
-                    </a:lnB>
                   </a:tcPr>
                 </a:tc>
                 <a:tc>
                   <a:txBody>
-                    <a:bodyPr wrap="square" lIns="150000" rIns="150000" tIns="90000" bIns="90000"/>
+                    <a:bodyPr/>
                     <a:lstStyle/>
                     <a:p>
                       <a:pPr algn="l">
@@ -4118,30 +4073,40 @@
                         </a:spcAft>
                       </a:pPr>
                       <a:r>
-                        <a:rPr sz="1400" b="1" i="0">
+                        <a:rPr lang="en-US" sz="1400" b="1" i="0" dirty="0">
+                          <a:solidFill>
+                            <a:srgbClr val="C00000"/>
+                          </a:solidFill>
+                          <a:latin typeface="Calibri"/>
+                        </a:rPr>
+                        <a:t>Absorption</a:t>
+                      </a:r>
+                      <a:r>
+                        <a:rPr lang="en-US" sz="1400" b="1" i="0" dirty="0">
                           <a:solidFill>
                             <a:srgbClr val="E8A33D"/>
                           </a:solidFill>
                           <a:latin typeface="Calibri"/>
                         </a:rPr>
-                        <a:t>Timing, not size</a:t>
+                        <a:t> </a:t>
                       </a:r>
+                      <a:endParaRPr sz="1400" b="1" i="0" dirty="0">
+                        <a:solidFill>
+                          <a:srgbClr val="E8A33D"/>
+                        </a:solidFill>
+                        <a:latin typeface="Calibri"/>
+                      </a:endParaRPr>
                     </a:p>
                   </a:txBody>
                   <a:tcPr anchor="ctr">
                     <a:solidFill>
                       <a:srgbClr val="1A2337"/>
                     </a:solidFill>
-                    <a:lnB w="9525" cap="flat">
-                      <a:solidFill>
-                        <a:srgbClr val="27334B"/>
-                      </a:solidFill>
-                    </a:lnB>
                   </a:tcPr>
                 </a:tc>
                 <a:tc>
                   <a:txBody>
-                    <a:bodyPr wrap="square" lIns="150000" rIns="150000" tIns="90000" bIns="90000"/>
+                    <a:bodyPr/>
                     <a:lstStyle/>
                     <a:p>
                       <a:pPr algn="l">
@@ -4156,7 +4121,7 @@
                         </a:spcAft>
                       </a:pPr>
                       <a:r>
-                        <a:rPr sz="1500" b="1" i="0">
+                        <a:rPr sz="1500" b="1" i="0" dirty="0">
                           <a:solidFill>
                             <a:srgbClr val="3FD9A0"/>
                           </a:solidFill>
@@ -4178,32 +4143,56 @@
                         </a:spcAft>
                       </a:pPr>
                       <a:r>
-                        <a:rPr sz="1350" b="0" i="0">
+                        <a:rPr lang="en-US" sz="1350" b="0" i="0" dirty="0">
                           <a:solidFill>
                             <a:srgbClr val="9AA7BD"/>
                           </a:solidFill>
                           <a:latin typeface="Calibri"/>
                         </a:rPr>
-                        <a:t>Commit the full number; stage the clock so the change lands after the crunch.</a:t>
+                        <a:t>Stage commitments </a:t>
                       </a:r>
+                      <a:r>
+                        <a:rPr sz="1350" b="0" i="0" dirty="0">
+                          <a:solidFill>
+                            <a:srgbClr val="9AA7BD"/>
+                          </a:solidFill>
+                          <a:latin typeface="Calibri"/>
+                        </a:rPr>
+                        <a:t>so the change lands </a:t>
+                      </a:r>
+                      <a:r>
+                        <a:rPr lang="en-US" sz="1350" b="0" i="0" dirty="0">
+                          <a:solidFill>
+                            <a:srgbClr val="9AA7BD"/>
+                          </a:solidFill>
+                          <a:latin typeface="Calibri"/>
+                        </a:rPr>
+                        <a:t>after crunch periods </a:t>
+                      </a:r>
+                      <a:endParaRPr sz="1350" b="0" i="0" dirty="0">
+                        <a:solidFill>
+                          <a:srgbClr val="9AA7BD"/>
+                        </a:solidFill>
+                        <a:latin typeface="Calibri"/>
+                      </a:endParaRPr>
                     </a:p>
                   </a:txBody>
                   <a:tcPr anchor="ctr">
                     <a:solidFill>
                       <a:srgbClr val="1A2337"/>
                     </a:solidFill>
-                    <a:lnB w="9525" cap="flat">
-                      <a:solidFill>
-                        <a:srgbClr val="27334B"/>
-                      </a:solidFill>
-                    </a:lnB>
                   </a:tcPr>
                 </a:tc>
+                <a:extLst>
+                  <a:ext uri="{0D108BD9-81ED-4DB2-BD59-A6C34878D82A}">
+                    <a16:rowId xmlns:a16="http://schemas.microsoft.com/office/drawing/2014/main" val="10001"/>
+                  </a:ext>
+                </a:extLst>
               </a:tr>
               <a:tr h="857000">
                 <a:tc>
                   <a:txBody>
-                    <a:bodyPr wrap="square" lIns="150000" rIns="150000" tIns="90000" bIns="90000"/>
+                    <a:bodyPr/>
                     <a:lstStyle/>
                     <a:p>
                       <a:pPr algn="l">
@@ -4218,7 +4207,7 @@
                         </a:spcAft>
                       </a:pPr>
                       <a:r>
-                        <a:rPr sz="1550" b="1" i="0">
+                        <a:rPr sz="1550" b="1" i="0" dirty="0">
                           <a:solidFill>
                             <a:srgbClr val="FFFFFF"/>
                           </a:solidFill>
@@ -4232,16 +4221,11 @@
                     <a:solidFill>
                       <a:srgbClr val="1A2337"/>
                     </a:solidFill>
-                    <a:lnB w="9525" cap="flat">
-                      <a:solidFill>
-                        <a:srgbClr val="27334B"/>
-                      </a:solidFill>
-                    </a:lnB>
                   </a:tcPr>
                 </a:tc>
                 <a:tc>
                   <a:txBody>
-                    <a:bodyPr wrap="square" lIns="150000" rIns="150000" tIns="90000" bIns="90000"/>
+                    <a:bodyPr/>
                     <a:lstStyle/>
                     <a:p>
                       <a:pPr algn="l">
@@ -4256,30 +4240,31 @@
                         </a:spcAft>
                       </a:pPr>
                       <a:r>
-                        <a:rPr sz="1400" b="1" i="0">
+                        <a:rPr lang="en-US" sz="1400" b="1" i="0" dirty="0">
                           <a:solidFill>
-                            <a:srgbClr val="4FC3D9"/>
+                            <a:srgbClr val="C00000"/>
                           </a:solidFill>
                           <a:latin typeface="Calibri"/>
                         </a:rPr>
-                        <a:t>A paid-for head start</a:t>
+                        <a:t>Advantage</a:t>
                       </a:r>
+                      <a:endParaRPr sz="1400" b="1" i="0" dirty="0">
+                        <a:solidFill>
+                          <a:srgbClr val="C00000"/>
+                        </a:solidFill>
+                        <a:latin typeface="Calibri"/>
+                      </a:endParaRPr>
                     </a:p>
                   </a:txBody>
                   <a:tcPr anchor="ctr">
                     <a:solidFill>
                       <a:srgbClr val="1A2337"/>
                     </a:solidFill>
-                    <a:lnB w="9525" cap="flat">
-                      <a:solidFill>
-                        <a:srgbClr val="27334B"/>
-                      </a:solidFill>
-                    </a:lnB>
                   </a:tcPr>
                 </a:tc>
                 <a:tc>
                   <a:txBody>
-                    <a:bodyPr wrap="square" lIns="150000" rIns="150000" tIns="90000" bIns="90000"/>
+                    <a:bodyPr/>
                     <a:lstStyle/>
                     <a:p>
                       <a:pPr algn="l">
@@ -4294,7 +4279,7 @@
                         </a:spcAft>
                       </a:pPr>
                       <a:r>
-                        <a:rPr sz="1500" b="1" i="0">
+                        <a:rPr sz="1500" b="1" i="0" dirty="0">
                           <a:solidFill>
                             <a:srgbClr val="3FD9A0"/>
                           </a:solidFill>
@@ -4316,13 +4301,195 @@
                         </a:spcAft>
                       </a:pPr>
                       <a:r>
-                        <a:rPr sz="1350" b="0" i="0">
+                        <a:rPr sz="1350" b="0" i="0" dirty="0">
                           <a:solidFill>
                             <a:srgbClr val="9AA7BD"/>
                           </a:solidFill>
                           <a:latin typeface="Calibri"/>
                         </a:rPr>
-                        <a:t>Credit what they already built and guarantee them the demand, so sharing pays.</a:t>
+                        <a:t>Credit what they already built and guarantee them the demand, so sharing </a:t>
+                      </a:r>
+                      <a:r>
+                        <a:rPr lang="en-US" sz="1350" b="0" i="0" dirty="0">
+                          <a:solidFill>
+                            <a:srgbClr val="9AA7BD"/>
+                          </a:solidFill>
+                          <a:latin typeface="Calibri"/>
+                        </a:rPr>
+                        <a:t>benefits them</a:t>
+                      </a:r>
+                      <a:endParaRPr sz="1350" b="0" i="0" dirty="0">
+                        <a:solidFill>
+                          <a:srgbClr val="9AA7BD"/>
+                        </a:solidFill>
+                        <a:latin typeface="Calibri"/>
+                      </a:endParaRPr>
+                    </a:p>
+                  </a:txBody>
+                  <a:tcPr anchor="ctr">
+                    <a:solidFill>
+                      <a:srgbClr val="1A2337"/>
+                    </a:solidFill>
+                  </a:tcPr>
+                </a:tc>
+                <a:extLst>
+                  <a:ext uri="{0D108BD9-81ED-4DB2-BD59-A6C34878D82A}">
+                    <a16:rowId xmlns:a16="http://schemas.microsoft.com/office/drawing/2014/main" val="10002"/>
+                  </a:ext>
+                </a:extLst>
+              </a:tr>
+              <a:tr h="857000">
+                <a:tc>
+                  <a:txBody>
+                    <a:bodyPr/>
+                    <a:lstStyle/>
+                    <a:p>
+                      <a:pPr algn="l">
+                        <a:lnSpc>
+                          <a:spcPct val="105000"/>
+                        </a:lnSpc>
+                        <a:spcBef>
+                          <a:spcPts val="0"/>
+                        </a:spcBef>
+                        <a:spcAft>
+                          <a:spcPts val="0"/>
+                        </a:spcAft>
+                      </a:pPr>
+                      <a:r>
+                        <a:rPr sz="1550" b="1" i="0" dirty="0">
+                          <a:solidFill>
+                            <a:srgbClr val="FFFFFF"/>
+                          </a:solidFill>
+                          <a:latin typeface="Calibri"/>
+                        </a:rPr>
+                        <a:t>"</a:t>
+                      </a:r>
+                      <a:r>
+                        <a:rPr lang="en-US" sz="1550" b="1" i="0" dirty="0">
+                          <a:solidFill>
+                            <a:srgbClr val="FFFFFF"/>
+                          </a:solidFill>
+                          <a:latin typeface="Calibri"/>
+                        </a:rPr>
+                        <a:t>Commitments last time were not followed through” </a:t>
+                      </a:r>
+                      <a:endParaRPr sz="1550" b="1" i="0" dirty="0">
+                        <a:solidFill>
+                          <a:srgbClr val="FFFFFF"/>
+                        </a:solidFill>
+                        <a:latin typeface="Calibri"/>
+                      </a:endParaRPr>
+                    </a:p>
+                  </a:txBody>
+                  <a:tcPr anchor="ctr">
+                    <a:solidFill>
+                      <a:srgbClr val="1A2337"/>
+                    </a:solidFill>
+                  </a:tcPr>
+                </a:tc>
+                <a:tc>
+                  <a:txBody>
+                    <a:bodyPr/>
+                    <a:lstStyle/>
+                    <a:p>
+                      <a:pPr algn="l">
+                        <a:lnSpc>
+                          <a:spcPct val="105000"/>
+                        </a:lnSpc>
+                        <a:spcBef>
+                          <a:spcPts val="0"/>
+                        </a:spcBef>
+                        <a:spcAft>
+                          <a:spcPts val="0"/>
+                        </a:spcAft>
+                      </a:pPr>
+                      <a:r>
+                        <a:rPr lang="en-US" sz="1400" b="1" i="0" dirty="0">
+                          <a:solidFill>
+                            <a:srgbClr val="C00000"/>
+                          </a:solidFill>
+                          <a:latin typeface="Calibri"/>
+                        </a:rPr>
+                        <a:t>Assurance</a:t>
+                      </a:r>
+                      <a:endParaRPr sz="1400" b="1" i="0" dirty="0">
+                        <a:solidFill>
+                          <a:srgbClr val="C00000"/>
+                        </a:solidFill>
+                        <a:latin typeface="Calibri"/>
+                      </a:endParaRPr>
+                    </a:p>
+                  </a:txBody>
+                  <a:tcPr anchor="ctr">
+                    <a:solidFill>
+                      <a:srgbClr val="1A2337"/>
+                    </a:solidFill>
+                  </a:tcPr>
+                </a:tc>
+                <a:tc>
+                  <a:txBody>
+                    <a:bodyPr/>
+                    <a:lstStyle/>
+                    <a:p>
+                      <a:pPr algn="l">
+                        <a:lnSpc>
+                          <a:spcPct val="100000"/>
+                        </a:lnSpc>
+                        <a:spcBef>
+                          <a:spcPts val="0"/>
+                        </a:spcBef>
+                        <a:spcAft>
+                          <a:spcPts val="300"/>
+                        </a:spcAft>
+                      </a:pPr>
+                      <a:r>
+                        <a:rPr sz="1500" b="1" i="0" dirty="0">
+                          <a:solidFill>
+                            <a:srgbClr val="3FD9A0"/>
+                          </a:solidFill>
+                          <a:latin typeface="Calibri"/>
+                        </a:rPr>
+                        <a:t>UNDERWRITE</a:t>
+                      </a:r>
+                    </a:p>
+                    <a:p>
+                      <a:pPr algn="l">
+                        <a:lnSpc>
+                          <a:spcPct val="106000"/>
+                        </a:lnSpc>
+                        <a:spcBef>
+                          <a:spcPts val="0"/>
+                        </a:spcBef>
+                        <a:spcAft>
+                          <a:spcPts val="0"/>
+                        </a:spcAft>
+                      </a:pPr>
+                      <a:r>
+                        <a:rPr sz="1350" b="0" i="0" dirty="0">
+                          <a:solidFill>
+                            <a:srgbClr val="9AA7BD"/>
+                          </a:solidFill>
+                          <a:latin typeface="Calibri"/>
+                        </a:rPr>
+                        <a:t>Cap the downside, cover the migration</a:t>
+                      </a:r>
+                      <a:r>
+                        <a:rPr lang="en-US" sz="1350" b="0" i="0" dirty="0">
+                          <a:solidFill>
+                            <a:srgbClr val="9AA7BD"/>
+                          </a:solidFill>
+                          <a:latin typeface="Calibri"/>
+                        </a:rPr>
+                        <a:t> and</a:t>
+                      </a:r>
+                      <a:r>
+                        <a:rPr sz="1350" b="0" i="0" dirty="0">
+                          <a:solidFill>
+                            <a:srgbClr val="9AA7BD"/>
+                          </a:solidFill>
+                          <a:latin typeface="Calibri"/>
+                        </a:rPr>
+                        <a:t> guarantee access</a:t>
                       </a:r>
                     </a:p>
                   </a:txBody>
@@ -4330,18 +4497,18 @@
                     <a:solidFill>
                       <a:srgbClr val="1A2337"/>
                     </a:solidFill>
-                    <a:lnB w="9525" cap="flat">
-                      <a:solidFill>
-                        <a:srgbClr val="27334B"/>
-                      </a:solidFill>
-                    </a:lnB>
                   </a:tcPr>
                 </a:tc>
+                <a:extLst>
+                  <a:ext uri="{0D108BD9-81ED-4DB2-BD59-A6C34878D82A}">
+                    <a16:rowId xmlns:a16="http://schemas.microsoft.com/office/drawing/2014/main" val="10004"/>
+                  </a:ext>
+                </a:extLst>
               </a:tr>
               <a:tr h="857000">
                 <a:tc>
                   <a:txBody>
-                    <a:bodyPr wrap="square" lIns="150000" rIns="150000" tIns="90000" bIns="90000"/>
+                    <a:bodyPr/>
                     <a:lstStyle/>
                     <a:p>
                       <a:pPr algn="l">
@@ -4370,16 +4537,11 @@
                     <a:solidFill>
                       <a:srgbClr val="1A2337"/>
                     </a:solidFill>
-                    <a:lnB w="9525" cap="flat">
-                      <a:solidFill>
-                        <a:srgbClr val="27334B"/>
-                      </a:solidFill>
-                    </a:lnB>
                   </a:tcPr>
                 </a:tc>
                 <a:tc>
                   <a:txBody>
-                    <a:bodyPr wrap="square" lIns="150000" rIns="150000" tIns="90000" bIns="90000"/>
+                    <a:bodyPr/>
                     <a:lstStyle/>
                     <a:p>
                       <a:pPr algn="l">
@@ -4394,9 +4556,9 @@
                         </a:spcAft>
                       </a:pPr>
                       <a:r>
-                        <a:rPr sz="1400" b="1" i="0">
+                        <a:rPr sz="1400" b="1" i="0" dirty="0">
                           <a:solidFill>
-                            <a:srgbClr val="4FC3D9"/>
+                            <a:srgbClr val="C00000"/>
                           </a:solidFill>
                           <a:latin typeface="Calibri"/>
                         </a:rPr>
@@ -4408,16 +4570,11 @@
                     <a:solidFill>
                       <a:srgbClr val="1A2337"/>
                     </a:solidFill>
-                    <a:lnB w="9525" cap="flat">
-                      <a:solidFill>
-                        <a:srgbClr val="27334B"/>
-                      </a:solidFill>
-                    </a:lnB>
                   </a:tcPr>
                 </a:tc>
                 <a:tc>
                   <a:txBody>
-                    <a:bodyPr wrap="square" lIns="150000" rIns="150000" tIns="90000" bIns="90000"/>
+                    <a:bodyPr/>
                     <a:lstStyle/>
                     <a:p>
                       <a:pPr algn="l">
@@ -4432,7 +4589,7 @@
                         </a:spcAft>
                       </a:pPr>
                       <a:r>
-                        <a:rPr sz="1500" b="1" i="0">
+                        <a:rPr sz="1500" b="1" i="0" dirty="0">
                           <a:solidFill>
                             <a:srgbClr val="3FD9A0"/>
                           </a:solidFill>
@@ -4454,215 +4611,47 @@
                         </a:spcAft>
                       </a:pPr>
                       <a:r>
-                        <a:rPr sz="1350" b="0" i="0">
+                        <a:rPr sz="1350" b="0" i="0" dirty="0">
                           <a:solidFill>
                             <a:srgbClr val="9AA7BD"/>
                           </a:solidFill>
                           <a:latin typeface="Calibri"/>
                         </a:rPr>
-                        <a:t>Make them the owner the others build on — they keep the lead as they share it.</a:t>
+                        <a:t>Make them the owner the others build on</a:t>
                       </a:r>
+                      <a:r>
+                        <a:rPr lang="en-US" sz="1350" b="0" i="0" dirty="0">
+                          <a:solidFill>
+                            <a:srgbClr val="9AA7BD"/>
+                          </a:solidFill>
+                          <a:latin typeface="Calibri"/>
+                        </a:rPr>
+                        <a:t>, and recognize status</a:t>
+                      </a:r>
+                      <a:endParaRPr sz="1350" b="0" i="0" dirty="0">
+                        <a:solidFill>
+                          <a:srgbClr val="9AA7BD"/>
+                        </a:solidFill>
+                        <a:latin typeface="Calibri"/>
+                      </a:endParaRPr>
                     </a:p>
                   </a:txBody>
                   <a:tcPr anchor="ctr">
                     <a:solidFill>
                       <a:srgbClr val="1A2337"/>
                     </a:solidFill>
-                    <a:lnB w="9525" cap="flat">
-                      <a:solidFill>
-                        <a:srgbClr val="27334B"/>
-                      </a:solidFill>
-                    </a:lnB>
                   </a:tcPr>
                 </a:tc>
-              </a:tr>
-              <a:tr h="857000">
-                <a:tc>
-                  <a:txBody>
-                    <a:bodyPr wrap="square" lIns="150000" rIns="150000" tIns="90000" bIns="90000"/>
-                    <a:lstStyle/>
-                    <a:p>
-                      <a:pPr algn="l">
-                        <a:lnSpc>
-                          <a:spcPct val="105000"/>
-                        </a:lnSpc>
-                        <a:spcBef>
-                          <a:spcPts val="0"/>
-                        </a:spcBef>
-                        <a:spcAft>
-                          <a:spcPts val="0"/>
-                        </a:spcAft>
-                      </a:pPr>
-                      <a:r>
-                        <a:rPr sz="1550" b="1" i="0">
-                          <a:solidFill>
-                            <a:srgbClr val="FFFFFF"/>
-                          </a:solidFill>
-                          <a:latin typeface="Calibri"/>
-                        </a:rPr>
-                        <a:t>"Last time, we ate the cost."</a:t>
-                      </a:r>
-                    </a:p>
-                  </a:txBody>
-                  <a:tcPr anchor="ctr">
-                    <a:solidFill>
-                      <a:srgbClr val="1A2337"/>
-                    </a:solidFill>
-                    <a:lnB w="9525" cap="flat">
-                      <a:solidFill>
-                        <a:srgbClr val="27334B"/>
-                      </a:solidFill>
-                    </a:lnB>
-                  </a:tcPr>
-                </a:tc>
-                <a:tc>
-                  <a:txBody>
-                    <a:bodyPr wrap="square" lIns="150000" rIns="150000" tIns="90000" bIns="90000"/>
-                    <a:lstStyle/>
-                    <a:p>
-                      <a:pPr algn="l">
-                        <a:lnSpc>
-                          <a:spcPct val="105000"/>
-                        </a:lnSpc>
-                        <a:spcBef>
-                          <a:spcPts val="0"/>
-                        </a:spcBef>
-                        <a:spcAft>
-                          <a:spcPts val="0"/>
-                        </a:spcAft>
-                      </a:pPr>
-                      <a:r>
-                        <a:rPr sz="1400" b="1" i="0">
-                          <a:solidFill>
-                            <a:srgbClr val="A78BFA"/>
-                          </a:solidFill>
-                          <a:latin typeface="Calibri"/>
-                        </a:rPr>
-                        <a:t>Broken trust</a:t>
-                      </a:r>
-                    </a:p>
-                  </a:txBody>
-                  <a:tcPr anchor="ctr">
-                    <a:solidFill>
-                      <a:srgbClr val="1A2337"/>
-                    </a:solidFill>
-                    <a:lnB w="9525" cap="flat">
-                      <a:solidFill>
-                        <a:srgbClr val="27334B"/>
-                      </a:solidFill>
-                    </a:lnB>
-                  </a:tcPr>
-                </a:tc>
-                <a:tc>
-                  <a:txBody>
-                    <a:bodyPr wrap="square" lIns="150000" rIns="150000" tIns="90000" bIns="90000"/>
-                    <a:lstStyle/>
-                    <a:p>
-                      <a:pPr algn="l">
-                        <a:lnSpc>
-                          <a:spcPct val="100000"/>
-                        </a:lnSpc>
-                        <a:spcBef>
-                          <a:spcPts val="0"/>
-                        </a:spcBef>
-                        <a:spcAft>
-                          <a:spcPts val="300"/>
-                        </a:spcAft>
-                      </a:pPr>
-                      <a:r>
-                        <a:rPr sz="1500" b="1" i="0">
-                          <a:solidFill>
-                            <a:srgbClr val="3FD9A0"/>
-                          </a:solidFill>
-                          <a:latin typeface="Calibri"/>
-                        </a:rPr>
-                        <a:t>UNDERWRITE</a:t>
-                      </a:r>
-                    </a:p>
-                    <a:p>
-                      <a:pPr algn="l">
-                        <a:lnSpc>
-                          <a:spcPct val="106000"/>
-                        </a:lnSpc>
-                        <a:spcBef>
-                          <a:spcPts val="0"/>
-                        </a:spcBef>
-                        <a:spcAft>
-                          <a:spcPts val="0"/>
-                        </a:spcAft>
-                      </a:pPr>
-                      <a:r>
-                        <a:rPr sz="1350" b="0" i="0">
-                          <a:solidFill>
-                            <a:srgbClr val="9AA7BD"/>
-                          </a:solidFill>
-                          <a:latin typeface="Calibri"/>
-                        </a:rPr>
-                        <a:t>Cap the downside, cover the migration, guarantee access — in writing, before the pledge.</a:t>
-                      </a:r>
-                    </a:p>
-                  </a:txBody>
-                  <a:tcPr anchor="ctr">
-                    <a:solidFill>
-                      <a:srgbClr val="1A2337"/>
-                    </a:solidFill>
-                    <a:lnB w="9525" cap="flat">
-                      <a:solidFill>
-                        <a:srgbClr val="27334B"/>
-                      </a:solidFill>
-                    </a:lnB>
-                  </a:tcPr>
-                </a:tc>
+                <a:extLst>
+                  <a:ext uri="{0D108BD9-81ED-4DB2-BD59-A6C34878D82A}">
+                    <a16:rowId xmlns:a16="http://schemas.microsoft.com/office/drawing/2014/main" val="2473683815"/>
+                  </a:ext>
+                </a:extLst>
               </a:tr>
             </a:tbl>
           </a:graphicData>
         </a:graphic>
       </p:graphicFrame>
-      <p:sp>
-        <p:nvSpPr>
-          <p:cNvPr id="7" name="TextBox 6"/>
-          <p:cNvSpPr txBox="1"/>
-          <p:nvPr/>
-        </p:nvSpPr>
-        <p:spPr>
-          <a:xfrm>
-            <a:off x="610000" y="6320000"/>
-            <a:ext cx="10972000" cy="320000"/>
-          </a:xfrm>
-          <a:prstGeom prst="rect">
-            <a:avLst/>
-          </a:prstGeom>
-          <a:noFill/>
-        </p:spPr>
-        <p:txBody>
-          <a:bodyPr wrap="square" lIns="0" rIns="0" tIns="0" bIns="0">
-            <a:spAutoFit/>
-          </a:bodyPr>
-          <a:lstStyle/>
-          <a:p>
-            <a:pPr algn="l">
-              <a:lnSpc>
-                <a:spcPct val="105000"/>
-              </a:lnSpc>
-              <a:spcBef>
-                <a:spcPts val="0"/>
-              </a:spcBef>
-              <a:spcAft>
-                <a:spcPts val="0"/>
-              </a:spcAft>
-            </a:pPr>
-            <a:r>
-              <a:rPr sz="1450" b="1" i="0">
-                <a:solidFill>
-                  <a:srgbClr val="3FD9A0"/>
-                </a:solidFill>
-                <a:latin typeface="Calibri"/>
-              </a:rPr>
-              <a:t>One stakeholder can carry more than one blocker. Answer every one, or the commitment never comes.</a:t>
-            </a:r>
-          </a:p>
-        </p:txBody>
-      </p:sp>
     </p:spTree>
   </p:cSld>
   <p:clrMapOvr>

</xml_diff>